<commit_message>
Began working on storing data sets for Python plots in final presentation
</commit_message>
<xml_diff>
--- a/Biweekly Meetings/7_2_2026_hnaicker.pptx
+++ b/Biweekly Meetings/7_2_2026_hnaicker.pptx
@@ -124,19 +124,19 @@
 <pc:chgInfo xmlns:a="http://schemas.openxmlformats.org/drawingml/2006/main" xmlns:r="http://schemas.openxmlformats.org/officeDocument/2006/relationships" xmlns:ac="http://schemas.microsoft.com/office/drawing/2013/main/command" xmlns:pc="http://schemas.microsoft.com/office/powerpoint/2013/main/command">
   <pc:docChgLst>
     <pc:chgData name="Hari Vishwa Naicker" userId="b0a120ab-4096-4d7c-ad0a-0703db5c9336" providerId="ADAL" clId="{4DDE1817-2C02-46EF-B55F-C346D21C243D}"/>
-    <pc:docChg chg="undo custSel addSld delSld modSld">
-      <pc:chgData name="Hari Vishwa Naicker" userId="b0a120ab-4096-4d7c-ad0a-0703db5c9336" providerId="ADAL" clId="{4DDE1817-2C02-46EF-B55F-C346D21C243D}" dt="2026-07-02T13:57:48.779" v="1857" actId="1076"/>
+    <pc:docChg chg="undo custSel addSld delSld modSld sldOrd">
+      <pc:chgData name="Hari Vishwa Naicker" userId="b0a120ab-4096-4d7c-ad0a-0703db5c9336" providerId="ADAL" clId="{4DDE1817-2C02-46EF-B55F-C346D21C243D}" dt="2026-07-02T17:45:02.637" v="1985" actId="20577"/>
       <pc:docMkLst>
         <pc:docMk/>
       </pc:docMkLst>
       <pc:sldChg chg="modSp mod">
-        <pc:chgData name="Hari Vishwa Naicker" userId="b0a120ab-4096-4d7c-ad0a-0703db5c9336" providerId="ADAL" clId="{4DDE1817-2C02-46EF-B55F-C346D21C243D}" dt="2026-07-01T14:12:11.955" v="60" actId="20577"/>
+        <pc:chgData name="Hari Vishwa Naicker" userId="b0a120ab-4096-4d7c-ad0a-0703db5c9336" providerId="ADAL" clId="{4DDE1817-2C02-46EF-B55F-C346D21C243D}" dt="2026-07-02T17:27:17.610" v="1881" actId="20577"/>
         <pc:sldMkLst>
           <pc:docMk/>
           <pc:sldMk cId="1665996140" sldId="256"/>
         </pc:sldMkLst>
         <pc:spChg chg="mod">
-          <ac:chgData name="Hari Vishwa Naicker" userId="b0a120ab-4096-4d7c-ad0a-0703db5c9336" providerId="ADAL" clId="{4DDE1817-2C02-46EF-B55F-C346D21C243D}" dt="2026-07-01T14:12:11.955" v="60" actId="20577"/>
+          <ac:chgData name="Hari Vishwa Naicker" userId="b0a120ab-4096-4d7c-ad0a-0703db5c9336" providerId="ADAL" clId="{4DDE1817-2C02-46EF-B55F-C346D21C243D}" dt="2026-07-02T17:27:17.610" v="1881" actId="20577"/>
           <ac:spMkLst>
             <pc:docMk/>
             <pc:sldMk cId="1665996140" sldId="256"/>
@@ -184,7 +184,7 @@
         </pc:picChg>
       </pc:sldChg>
       <pc:sldChg chg="modSp new mod">
-        <pc:chgData name="Hari Vishwa Naicker" userId="b0a120ab-4096-4d7c-ad0a-0703db5c9336" providerId="ADAL" clId="{4DDE1817-2C02-46EF-B55F-C346D21C243D}" dt="2026-07-01T22:14:44.980" v="1795" actId="20577"/>
+        <pc:chgData name="Hari Vishwa Naicker" userId="b0a120ab-4096-4d7c-ad0a-0703db5c9336" providerId="ADAL" clId="{4DDE1817-2C02-46EF-B55F-C346D21C243D}" dt="2026-07-02T17:45:02.637" v="1985" actId="20577"/>
         <pc:sldMkLst>
           <pc:docMk/>
           <pc:sldMk cId="2847214781" sldId="259"/>
@@ -198,7 +198,7 @@
           </ac:spMkLst>
         </pc:spChg>
         <pc:spChg chg="mod">
-          <ac:chgData name="Hari Vishwa Naicker" userId="b0a120ab-4096-4d7c-ad0a-0703db5c9336" providerId="ADAL" clId="{4DDE1817-2C02-46EF-B55F-C346D21C243D}" dt="2026-07-01T22:14:44.980" v="1795" actId="20577"/>
+          <ac:chgData name="Hari Vishwa Naicker" userId="b0a120ab-4096-4d7c-ad0a-0703db5c9336" providerId="ADAL" clId="{4DDE1817-2C02-46EF-B55F-C346D21C243D}" dt="2026-07-02T17:45:02.637" v="1985" actId="20577"/>
           <ac:spMkLst>
             <pc:docMk/>
             <pc:sldMk cId="2847214781" sldId="259"/>
@@ -214,7 +214,7 @@
         </pc:sldMkLst>
       </pc:sldChg>
       <pc:sldChg chg="modSp new mod">
-        <pc:chgData name="Hari Vishwa Naicker" userId="b0a120ab-4096-4d7c-ad0a-0703db5c9336" providerId="ADAL" clId="{4DDE1817-2C02-46EF-B55F-C346D21C243D}" dt="2026-07-01T21:43:40.170" v="1191" actId="20577"/>
+        <pc:chgData name="Hari Vishwa Naicker" userId="b0a120ab-4096-4d7c-ad0a-0703db5c9336" providerId="ADAL" clId="{4DDE1817-2C02-46EF-B55F-C346D21C243D}" dt="2026-07-02T17:34:27.280" v="1961" actId="20577"/>
         <pc:sldMkLst>
           <pc:docMk/>
           <pc:sldMk cId="3456192196" sldId="261"/>
@@ -228,7 +228,7 @@
           </ac:spMkLst>
         </pc:spChg>
         <pc:spChg chg="mod">
-          <ac:chgData name="Hari Vishwa Naicker" userId="b0a120ab-4096-4d7c-ad0a-0703db5c9336" providerId="ADAL" clId="{4DDE1817-2C02-46EF-B55F-C346D21C243D}" dt="2026-07-01T21:43:40.170" v="1191" actId="20577"/>
+          <ac:chgData name="Hari Vishwa Naicker" userId="b0a120ab-4096-4d7c-ad0a-0703db5c9336" providerId="ADAL" clId="{4DDE1817-2C02-46EF-B55F-C346D21C243D}" dt="2026-07-02T17:34:27.280" v="1961" actId="20577"/>
           <ac:spMkLst>
             <pc:docMk/>
             <pc:sldMk cId="3456192196" sldId="261"/>
@@ -236,8 +236,8 @@
           </ac:spMkLst>
         </pc:spChg>
       </pc:sldChg>
-      <pc:sldChg chg="addSp modSp new mod">
-        <pc:chgData name="Hari Vishwa Naicker" userId="b0a120ab-4096-4d7c-ad0a-0703db5c9336" providerId="ADAL" clId="{4DDE1817-2C02-46EF-B55F-C346D21C243D}" dt="2026-07-02T13:57:48.779" v="1857" actId="1076"/>
+      <pc:sldChg chg="addSp modSp new mod ord">
+        <pc:chgData name="Hari Vishwa Naicker" userId="b0a120ab-4096-4d7c-ad0a-0703db5c9336" providerId="ADAL" clId="{4DDE1817-2C02-46EF-B55F-C346D21C243D}" dt="2026-07-02T16:31:43.116" v="1859"/>
         <pc:sldMkLst>
           <pc:docMk/>
           <pc:sldMk cId="2558830728" sldId="262"/>
@@ -6435,10 +6435,7 @@
                 <a:spcPts val="500"/>
               </a:spcBef>
             </a:pPr>
-            <a:r>
-              <a:rPr lang="en-US" sz="2400" b="0" dirty="0"/>
-              <a:t>Click to edit subtitle</a:t>
-            </a:r>
+            <a:endParaRPr lang="en-US" sz="2400" b="0" dirty="0"/>
           </a:p>
         </p:txBody>
       </p:sp>
@@ -6577,6 +6574,15 @@
             <a:r>
               <a:rPr lang="en-US" dirty="0"/>
               <a:t>Improved NCFL in preparation for Python integration with additional control settings, higher fidelity components(HX and heaters), and easier to update dimensions. </a:t>
+            </a:r>
+          </a:p>
+          <a:p>
+            <a:pPr marL="457200" indent="-457200">
+              <a:buAutoNum type="arabicPeriod"/>
+            </a:pPr>
+            <a:r>
+              <a:rPr lang="en-US" dirty="0"/>
+              <a:t>Met with Jack and Linyu individually.</a:t>
             </a:r>
           </a:p>
           <a:p>
@@ -7182,7 +7188,7 @@
           <a:p>
             <a:r>
               <a:rPr lang="en-US" dirty="0"/>
-              <a:t>Future Plans:</a:t>
+              <a:t>Future Objectives:</a:t>
             </a:r>
           </a:p>
           <a:p>
@@ -7224,13 +7230,16 @@
             <a:pPr lvl="1"/>
             <a:r>
               <a:rPr lang="en-US" dirty="0"/>
-              <a:t>Ran into some trouble with installing </a:t>
+              <a:t>Ran into some trouble with </a:t>
             </a:r>
             <a:r>
               <a:rPr lang="en-US" dirty="0" err="1"/>
               <a:t>DeepLynx</a:t>
             </a:r>
-            <a:endParaRPr lang="en-US" dirty="0"/>
+            <a:r>
+              <a:rPr lang="en-US" dirty="0"/>
+              <a:t> installation</a:t>
+            </a:r>
           </a:p>
           <a:p>
             <a:endParaRPr lang="en-US" dirty="0"/>
@@ -7840,15 +7849,6 @@
 </file>
 
 <file path=customXml/item1.xml><?xml version="1.0" encoding="utf-8"?>
-<?mso-contentType ?>
-<FormTemplates xmlns="http://schemas.microsoft.com/sharepoint/v3/contenttype/forms">
-  <Display>DocumentLibraryForm</Display>
-  <Edit>DocumentLibraryForm</Edit>
-  <New>DocumentLibraryForm</New>
-</FormTemplates>
-</file>
-
-<file path=customXml/item2.xml><?xml version="1.0" encoding="utf-8"?>
 <p:properties xmlns:p="http://schemas.microsoft.com/office/2006/metadata/properties" xmlns:xsi="http://www.w3.org/2001/XMLSchema-instance" xmlns:pc="http://schemas.microsoft.com/office/infopath/2007/PartnerControls">
   <documentManagement>
     <SharedWithUsers xmlns="2391d807-f94f-4c4f-bb14-493106c624c2">
@@ -7864,6 +7864,15 @@
     </lcf76f155ced4ddcb4097134ff3c332f>
   </documentManagement>
 </p:properties>
+</file>
+
+<file path=customXml/item2.xml><?xml version="1.0" encoding="utf-8"?>
+<?mso-contentType ?>
+<FormTemplates xmlns="http://schemas.microsoft.com/sharepoint/v3/contenttype/forms">
+  <Display>DocumentLibraryForm</Display>
+  <Edit>DocumentLibraryForm</Edit>
+  <New>DocumentLibraryForm</New>
+</FormTemplates>
 </file>
 
 <file path=customXml/item3.xml><?xml version="1.0" encoding="utf-8"?>
@@ -8082,20 +8091,20 @@
 </file>
 
 <file path=customXml/itemProps1.xml><?xml version="1.0" encoding="utf-8"?>
-<ds:datastoreItem xmlns:ds="http://schemas.openxmlformats.org/officeDocument/2006/customXml" ds:itemID="{5B987B27-07C2-425E-9FC8-8EB9D2FCBB97}">
-  <ds:schemaRefs>
-    <ds:schemaRef ds:uri="http://schemas.microsoft.com/sharepoint/v3/contenttype/forms"/>
-  </ds:schemaRefs>
-</ds:datastoreItem>
-</file>
-
-<file path=customXml/itemProps2.xml><?xml version="1.0" encoding="utf-8"?>
 <ds:datastoreItem xmlns:ds="http://schemas.openxmlformats.org/officeDocument/2006/customXml" ds:itemID="{52E72521-46AD-4BAF-8AA5-1067FA401909}">
   <ds:schemaRefs>
     <ds:schemaRef ds:uri="http://schemas.microsoft.com/office/2006/metadata/properties"/>
     <ds:schemaRef ds:uri="http://schemas.microsoft.com/office/infopath/2007/PartnerControls"/>
     <ds:schemaRef ds:uri="2391d807-f94f-4c4f-bb14-493106c624c2"/>
     <ds:schemaRef ds:uri="42ea9b75-b306-4826-8769-4c6ad6718b67"/>
+  </ds:schemaRefs>
+</ds:datastoreItem>
+</file>
+
+<file path=customXml/itemProps2.xml><?xml version="1.0" encoding="utf-8"?>
+<ds:datastoreItem xmlns:ds="http://schemas.openxmlformats.org/officeDocument/2006/customXml" ds:itemID="{5B987B27-07C2-425E-9FC8-8EB9D2FCBB97}">
+  <ds:schemaRefs>
+    <ds:schemaRef ds:uri="http://schemas.microsoft.com/sharepoint/v3/contenttype/forms"/>
   </ds:schemaRefs>
 </ds:datastoreItem>
 </file>

</xml_diff>